<commit_message>
chore(preview): secteur_Consumer_Defensive_S&P_500 outputs regeneres
</commit_message>
<xml_diff>
--- a/preview/secteur_Consumer_Defensive_S&P_500/secteur_Consumer_Defensive_S&P_500.pptx
+++ b/preview/secteur_Consumer_Defensive_S&P_500/secteur_Consumer_Defensive_S&P_500.pptx
@@ -11040,7 +11040,7 @@
                   <a:srgbClr val="FFFFFF"/>
                 </a:solidFill>
               </a:rPr>
-              <a:t>Zone d Entree Optimale</a:t>
+              <a:t>Zone d'Entree Optimale</a:t>
             </a:r>
           </a:p>
         </p:txBody>
@@ -13790,7 +13790,7 @@
                   <a:srgbClr val="FFFFFF"/>
                 </a:solidFill>
               </a:rPr>
-              <a:t>Risques &amp; Conditions d Invalidation</a:t>
+              <a:t>Risques &amp; Conditions d'Invalidation</a:t>
             </a:r>
           </a:p>
         </p:txBody>

</xml_diff>